<commit_message>
updating icon with transparent background, fix graphic in Readme with old tool name
</commit_message>
<xml_diff>
--- a/images/Grafik ETL MDreport.pptx
+++ b/images/Grafik ETL MDreport.pptx
@@ -155,10 +155,9 @@
           </a:lstStyle>
           <a:p>
             <a:r>
-              <a:rPr lang="de-DE" smtClean="0"/>
+              <a:rPr lang="de-DE"/>
               <a:t>Titelmasterformat durch Klicken bearbeiten</a:t>
             </a:r>
-            <a:endParaRPr lang="de-DE"/>
           </a:p>
         </p:txBody>
       </p:sp>
@@ -220,10 +219,9 @@
           </a:lstStyle>
           <a:p>
             <a:r>
-              <a:rPr lang="de-DE" smtClean="0"/>
+              <a:rPr lang="de-DE"/>
               <a:t>Formatvorlage des Untertitelmasters durch Klicken bearbeiten</a:t>
             </a:r>
-            <a:endParaRPr lang="de-DE"/>
           </a:p>
         </p:txBody>
       </p:sp>
@@ -244,7 +242,7 @@
           <a:p>
             <a:fld id="{25EB1AC2-4150-407C-A9A0-54E0CF37BB12}" type="datetimeFigureOut">
               <a:rPr lang="de-DE" smtClean="0"/>
-              <a:t>30.08.2023</a:t>
+              <a:t>11.08.2026</a:t>
             </a:fld>
             <a:endParaRPr lang="de-DE"/>
           </a:p>
@@ -338,10 +336,9 @@
           <a:lstStyle/>
           <a:p>
             <a:r>
-              <a:rPr lang="de-DE" smtClean="0"/>
+              <a:rPr lang="de-DE"/>
               <a:t>Titelmasterformat durch Klicken bearbeiten</a:t>
             </a:r>
-            <a:endParaRPr lang="de-DE"/>
           </a:p>
         </p:txBody>
       </p:sp>
@@ -362,38 +359,37 @@
           <a:p>
             <a:pPr lvl="0"/>
             <a:r>
-              <a:rPr lang="de-DE" smtClean="0"/>
+              <a:rPr lang="de-DE"/>
               <a:t>Textmasterformat bearbeiten</a:t>
             </a:r>
           </a:p>
           <a:p>
             <a:pPr lvl="1"/>
             <a:r>
-              <a:rPr lang="de-DE" smtClean="0"/>
+              <a:rPr lang="de-DE"/>
               <a:t>Zweite Ebene</a:t>
             </a:r>
           </a:p>
           <a:p>
             <a:pPr lvl="2"/>
             <a:r>
-              <a:rPr lang="de-DE" smtClean="0"/>
+              <a:rPr lang="de-DE"/>
               <a:t>Dritte Ebene</a:t>
             </a:r>
           </a:p>
           <a:p>
             <a:pPr lvl="3"/>
             <a:r>
-              <a:rPr lang="de-DE" smtClean="0"/>
+              <a:rPr lang="de-DE"/>
               <a:t>Vierte Ebene</a:t>
             </a:r>
           </a:p>
           <a:p>
             <a:pPr lvl="4"/>
             <a:r>
-              <a:rPr lang="de-DE" smtClean="0"/>
+              <a:rPr lang="de-DE"/>
               <a:t>Fünfte Ebene</a:t>
             </a:r>
-            <a:endParaRPr lang="de-DE"/>
           </a:p>
         </p:txBody>
       </p:sp>
@@ -414,7 +410,7 @@
           <a:p>
             <a:fld id="{25EB1AC2-4150-407C-A9A0-54E0CF37BB12}" type="datetimeFigureOut">
               <a:rPr lang="de-DE" smtClean="0"/>
-              <a:t>30.08.2023</a:t>
+              <a:t>11.08.2026</a:t>
             </a:fld>
             <a:endParaRPr lang="de-DE"/>
           </a:p>
@@ -513,10 +509,9 @@
           <a:lstStyle/>
           <a:p>
             <a:r>
-              <a:rPr lang="de-DE" smtClean="0"/>
+              <a:rPr lang="de-DE"/>
               <a:t>Titelmasterformat durch Klicken bearbeiten</a:t>
             </a:r>
-            <a:endParaRPr lang="de-DE"/>
           </a:p>
         </p:txBody>
       </p:sp>
@@ -542,38 +537,37 @@
           <a:p>
             <a:pPr lvl="0"/>
             <a:r>
-              <a:rPr lang="de-DE" smtClean="0"/>
+              <a:rPr lang="de-DE"/>
               <a:t>Textmasterformat bearbeiten</a:t>
             </a:r>
           </a:p>
           <a:p>
             <a:pPr lvl="1"/>
             <a:r>
-              <a:rPr lang="de-DE" smtClean="0"/>
+              <a:rPr lang="de-DE"/>
               <a:t>Zweite Ebene</a:t>
             </a:r>
           </a:p>
           <a:p>
             <a:pPr lvl="2"/>
             <a:r>
-              <a:rPr lang="de-DE" smtClean="0"/>
+              <a:rPr lang="de-DE"/>
               <a:t>Dritte Ebene</a:t>
             </a:r>
           </a:p>
           <a:p>
             <a:pPr lvl="3"/>
             <a:r>
-              <a:rPr lang="de-DE" smtClean="0"/>
+              <a:rPr lang="de-DE"/>
               <a:t>Vierte Ebene</a:t>
             </a:r>
           </a:p>
           <a:p>
             <a:pPr lvl="4"/>
             <a:r>
-              <a:rPr lang="de-DE" smtClean="0"/>
+              <a:rPr lang="de-DE"/>
               <a:t>Fünfte Ebene</a:t>
             </a:r>
-            <a:endParaRPr lang="de-DE"/>
           </a:p>
         </p:txBody>
       </p:sp>
@@ -594,7 +588,7 @@
           <a:p>
             <a:fld id="{25EB1AC2-4150-407C-A9A0-54E0CF37BB12}" type="datetimeFigureOut">
               <a:rPr lang="de-DE" smtClean="0"/>
-              <a:t>30.08.2023</a:t>
+              <a:t>11.08.2026</a:t>
             </a:fld>
             <a:endParaRPr lang="de-DE"/>
           </a:p>
@@ -688,10 +682,9 @@
           <a:lstStyle/>
           <a:p>
             <a:r>
-              <a:rPr lang="de-DE" smtClean="0"/>
+              <a:rPr lang="de-DE"/>
               <a:t>Titelmasterformat durch Klicken bearbeiten</a:t>
             </a:r>
-            <a:endParaRPr lang="de-DE"/>
           </a:p>
         </p:txBody>
       </p:sp>
@@ -712,38 +705,37 @@
           <a:p>
             <a:pPr lvl="0"/>
             <a:r>
-              <a:rPr lang="de-DE" smtClean="0"/>
+              <a:rPr lang="de-DE"/>
               <a:t>Textmasterformat bearbeiten</a:t>
             </a:r>
           </a:p>
           <a:p>
             <a:pPr lvl="1"/>
             <a:r>
-              <a:rPr lang="de-DE" smtClean="0"/>
+              <a:rPr lang="de-DE"/>
               <a:t>Zweite Ebene</a:t>
             </a:r>
           </a:p>
           <a:p>
             <a:pPr lvl="2"/>
             <a:r>
-              <a:rPr lang="de-DE" smtClean="0"/>
+              <a:rPr lang="de-DE"/>
               <a:t>Dritte Ebene</a:t>
             </a:r>
           </a:p>
           <a:p>
             <a:pPr lvl="3"/>
             <a:r>
-              <a:rPr lang="de-DE" smtClean="0"/>
+              <a:rPr lang="de-DE"/>
               <a:t>Vierte Ebene</a:t>
             </a:r>
           </a:p>
           <a:p>
             <a:pPr lvl="4"/>
             <a:r>
-              <a:rPr lang="de-DE" smtClean="0"/>
+              <a:rPr lang="de-DE"/>
               <a:t>Fünfte Ebene</a:t>
             </a:r>
-            <a:endParaRPr lang="de-DE"/>
           </a:p>
         </p:txBody>
       </p:sp>
@@ -764,7 +756,7 @@
           <a:p>
             <a:fld id="{25EB1AC2-4150-407C-A9A0-54E0CF37BB12}" type="datetimeFigureOut">
               <a:rPr lang="de-DE" smtClean="0"/>
-              <a:t>30.08.2023</a:t>
+              <a:t>11.08.2026</a:t>
             </a:fld>
             <a:endParaRPr lang="de-DE"/>
           </a:p>
@@ -867,10 +859,9 @@
           </a:lstStyle>
           <a:p>
             <a:r>
-              <a:rPr lang="de-DE" smtClean="0"/>
+              <a:rPr lang="de-DE"/>
               <a:t>Titelmasterformat durch Klicken bearbeiten</a:t>
             </a:r>
-            <a:endParaRPr lang="de-DE"/>
           </a:p>
         </p:txBody>
       </p:sp>
@@ -987,7 +978,7 @@
           <a:p>
             <a:pPr lvl="0"/>
             <a:r>
-              <a:rPr lang="de-DE" smtClean="0"/>
+              <a:rPr lang="de-DE"/>
               <a:t>Textmasterformat bearbeiten</a:t>
             </a:r>
           </a:p>
@@ -1010,7 +1001,7 @@
           <a:p>
             <a:fld id="{25EB1AC2-4150-407C-A9A0-54E0CF37BB12}" type="datetimeFigureOut">
               <a:rPr lang="de-DE" smtClean="0"/>
-              <a:t>30.08.2023</a:t>
+              <a:t>11.08.2026</a:t>
             </a:fld>
             <a:endParaRPr lang="de-DE"/>
           </a:p>
@@ -1104,10 +1095,9 @@
           <a:lstStyle/>
           <a:p>
             <a:r>
-              <a:rPr lang="de-DE" smtClean="0"/>
+              <a:rPr lang="de-DE"/>
               <a:t>Titelmasterformat durch Klicken bearbeiten</a:t>
             </a:r>
-            <a:endParaRPr lang="de-DE"/>
           </a:p>
         </p:txBody>
       </p:sp>
@@ -1133,38 +1123,37 @@
           <a:p>
             <a:pPr lvl="0"/>
             <a:r>
-              <a:rPr lang="de-DE" smtClean="0"/>
+              <a:rPr lang="de-DE"/>
               <a:t>Textmasterformat bearbeiten</a:t>
             </a:r>
           </a:p>
           <a:p>
             <a:pPr lvl="1"/>
             <a:r>
-              <a:rPr lang="de-DE" smtClean="0"/>
+              <a:rPr lang="de-DE"/>
               <a:t>Zweite Ebene</a:t>
             </a:r>
           </a:p>
           <a:p>
             <a:pPr lvl="2"/>
             <a:r>
-              <a:rPr lang="de-DE" smtClean="0"/>
+              <a:rPr lang="de-DE"/>
               <a:t>Dritte Ebene</a:t>
             </a:r>
           </a:p>
           <a:p>
             <a:pPr lvl="3"/>
             <a:r>
-              <a:rPr lang="de-DE" smtClean="0"/>
+              <a:rPr lang="de-DE"/>
               <a:t>Vierte Ebene</a:t>
             </a:r>
           </a:p>
           <a:p>
             <a:pPr lvl="4"/>
             <a:r>
-              <a:rPr lang="de-DE" smtClean="0"/>
+              <a:rPr lang="de-DE"/>
               <a:t>Fünfte Ebene</a:t>
             </a:r>
-            <a:endParaRPr lang="de-DE"/>
           </a:p>
         </p:txBody>
       </p:sp>
@@ -1190,38 +1179,37 @@
           <a:p>
             <a:pPr lvl="0"/>
             <a:r>
-              <a:rPr lang="de-DE" smtClean="0"/>
+              <a:rPr lang="de-DE"/>
               <a:t>Textmasterformat bearbeiten</a:t>
             </a:r>
           </a:p>
           <a:p>
             <a:pPr lvl="1"/>
             <a:r>
-              <a:rPr lang="de-DE" smtClean="0"/>
+              <a:rPr lang="de-DE"/>
               <a:t>Zweite Ebene</a:t>
             </a:r>
           </a:p>
           <a:p>
             <a:pPr lvl="2"/>
             <a:r>
-              <a:rPr lang="de-DE" smtClean="0"/>
+              <a:rPr lang="de-DE"/>
               <a:t>Dritte Ebene</a:t>
             </a:r>
           </a:p>
           <a:p>
             <a:pPr lvl="3"/>
             <a:r>
-              <a:rPr lang="de-DE" smtClean="0"/>
+              <a:rPr lang="de-DE"/>
               <a:t>Vierte Ebene</a:t>
             </a:r>
           </a:p>
           <a:p>
             <a:pPr lvl="4"/>
             <a:r>
-              <a:rPr lang="de-DE" smtClean="0"/>
+              <a:rPr lang="de-DE"/>
               <a:t>Fünfte Ebene</a:t>
             </a:r>
-            <a:endParaRPr lang="de-DE"/>
           </a:p>
         </p:txBody>
       </p:sp>
@@ -1242,7 +1230,7 @@
           <a:p>
             <a:fld id="{25EB1AC2-4150-407C-A9A0-54E0CF37BB12}" type="datetimeFigureOut">
               <a:rPr lang="de-DE" smtClean="0"/>
-              <a:t>30.08.2023</a:t>
+              <a:t>11.08.2026</a:t>
             </a:fld>
             <a:endParaRPr lang="de-DE"/>
           </a:p>
@@ -1341,10 +1329,9 @@
           <a:lstStyle/>
           <a:p>
             <a:r>
-              <a:rPr lang="de-DE" smtClean="0"/>
+              <a:rPr lang="de-DE"/>
               <a:t>Titelmasterformat durch Klicken bearbeiten</a:t>
             </a:r>
-            <a:endParaRPr lang="de-DE"/>
           </a:p>
         </p:txBody>
       </p:sp>
@@ -1407,7 +1394,7 @@
           <a:p>
             <a:pPr lvl="0"/>
             <a:r>
-              <a:rPr lang="de-DE" smtClean="0"/>
+              <a:rPr lang="de-DE"/>
               <a:t>Textmasterformat bearbeiten</a:t>
             </a:r>
           </a:p>
@@ -1435,38 +1422,37 @@
           <a:p>
             <a:pPr lvl="0"/>
             <a:r>
-              <a:rPr lang="de-DE" smtClean="0"/>
+              <a:rPr lang="de-DE"/>
               <a:t>Textmasterformat bearbeiten</a:t>
             </a:r>
           </a:p>
           <a:p>
             <a:pPr lvl="1"/>
             <a:r>
-              <a:rPr lang="de-DE" smtClean="0"/>
+              <a:rPr lang="de-DE"/>
               <a:t>Zweite Ebene</a:t>
             </a:r>
           </a:p>
           <a:p>
             <a:pPr lvl="2"/>
             <a:r>
-              <a:rPr lang="de-DE" smtClean="0"/>
+              <a:rPr lang="de-DE"/>
               <a:t>Dritte Ebene</a:t>
             </a:r>
           </a:p>
           <a:p>
             <a:pPr lvl="3"/>
             <a:r>
-              <a:rPr lang="de-DE" smtClean="0"/>
+              <a:rPr lang="de-DE"/>
               <a:t>Vierte Ebene</a:t>
             </a:r>
           </a:p>
           <a:p>
             <a:pPr lvl="4"/>
             <a:r>
-              <a:rPr lang="de-DE" smtClean="0"/>
+              <a:rPr lang="de-DE"/>
               <a:t>Fünfte Ebene</a:t>
             </a:r>
-            <a:endParaRPr lang="de-DE"/>
           </a:p>
         </p:txBody>
       </p:sp>
@@ -1529,7 +1515,7 @@
           <a:p>
             <a:pPr lvl="0"/>
             <a:r>
-              <a:rPr lang="de-DE" smtClean="0"/>
+              <a:rPr lang="de-DE"/>
               <a:t>Textmasterformat bearbeiten</a:t>
             </a:r>
           </a:p>
@@ -1557,38 +1543,37 @@
           <a:p>
             <a:pPr lvl="0"/>
             <a:r>
-              <a:rPr lang="de-DE" smtClean="0"/>
+              <a:rPr lang="de-DE"/>
               <a:t>Textmasterformat bearbeiten</a:t>
             </a:r>
           </a:p>
           <a:p>
             <a:pPr lvl="1"/>
             <a:r>
-              <a:rPr lang="de-DE" smtClean="0"/>
+              <a:rPr lang="de-DE"/>
               <a:t>Zweite Ebene</a:t>
             </a:r>
           </a:p>
           <a:p>
             <a:pPr lvl="2"/>
             <a:r>
-              <a:rPr lang="de-DE" smtClean="0"/>
+              <a:rPr lang="de-DE"/>
               <a:t>Dritte Ebene</a:t>
             </a:r>
           </a:p>
           <a:p>
             <a:pPr lvl="3"/>
             <a:r>
-              <a:rPr lang="de-DE" smtClean="0"/>
+              <a:rPr lang="de-DE"/>
               <a:t>Vierte Ebene</a:t>
             </a:r>
           </a:p>
           <a:p>
             <a:pPr lvl="4"/>
             <a:r>
-              <a:rPr lang="de-DE" smtClean="0"/>
+              <a:rPr lang="de-DE"/>
               <a:t>Fünfte Ebene</a:t>
             </a:r>
-            <a:endParaRPr lang="de-DE"/>
           </a:p>
         </p:txBody>
       </p:sp>
@@ -1609,7 +1594,7 @@
           <a:p>
             <a:fld id="{25EB1AC2-4150-407C-A9A0-54E0CF37BB12}" type="datetimeFigureOut">
               <a:rPr lang="de-DE" smtClean="0"/>
-              <a:t>30.08.2023</a:t>
+              <a:t>11.08.2026</a:t>
             </a:fld>
             <a:endParaRPr lang="de-DE"/>
           </a:p>
@@ -1703,10 +1688,9 @@
           <a:lstStyle/>
           <a:p>
             <a:r>
-              <a:rPr lang="de-DE" smtClean="0"/>
+              <a:rPr lang="de-DE"/>
               <a:t>Titelmasterformat durch Klicken bearbeiten</a:t>
             </a:r>
-            <a:endParaRPr lang="de-DE"/>
           </a:p>
         </p:txBody>
       </p:sp>
@@ -1727,7 +1711,7 @@
           <a:p>
             <a:fld id="{25EB1AC2-4150-407C-A9A0-54E0CF37BB12}" type="datetimeFigureOut">
               <a:rPr lang="de-DE" smtClean="0"/>
-              <a:t>30.08.2023</a:t>
+              <a:t>11.08.2026</a:t>
             </a:fld>
             <a:endParaRPr lang="de-DE"/>
           </a:p>
@@ -1822,7 +1806,7 @@
           <a:p>
             <a:fld id="{25EB1AC2-4150-407C-A9A0-54E0CF37BB12}" type="datetimeFigureOut">
               <a:rPr lang="de-DE" smtClean="0"/>
-              <a:t>30.08.2023</a:t>
+              <a:t>11.08.2026</a:t>
             </a:fld>
             <a:endParaRPr lang="de-DE"/>
           </a:p>
@@ -1925,10 +1909,9 @@
           </a:lstStyle>
           <a:p>
             <a:r>
-              <a:rPr lang="de-DE" smtClean="0"/>
+              <a:rPr lang="de-DE"/>
               <a:t>Titelmasterformat durch Klicken bearbeiten</a:t>
             </a:r>
-            <a:endParaRPr lang="de-DE"/>
           </a:p>
         </p:txBody>
       </p:sp>
@@ -1982,38 +1965,37 @@
           <a:p>
             <a:pPr lvl="0"/>
             <a:r>
-              <a:rPr lang="de-DE" smtClean="0"/>
+              <a:rPr lang="de-DE"/>
               <a:t>Textmasterformat bearbeiten</a:t>
             </a:r>
           </a:p>
           <a:p>
             <a:pPr lvl="1"/>
             <a:r>
-              <a:rPr lang="de-DE" smtClean="0"/>
+              <a:rPr lang="de-DE"/>
               <a:t>Zweite Ebene</a:t>
             </a:r>
           </a:p>
           <a:p>
             <a:pPr lvl="2"/>
             <a:r>
-              <a:rPr lang="de-DE" smtClean="0"/>
+              <a:rPr lang="de-DE"/>
               <a:t>Dritte Ebene</a:t>
             </a:r>
           </a:p>
           <a:p>
             <a:pPr lvl="3"/>
             <a:r>
-              <a:rPr lang="de-DE" smtClean="0"/>
+              <a:rPr lang="de-DE"/>
               <a:t>Vierte Ebene</a:t>
             </a:r>
           </a:p>
           <a:p>
             <a:pPr lvl="4"/>
             <a:r>
-              <a:rPr lang="de-DE" smtClean="0"/>
+              <a:rPr lang="de-DE"/>
               <a:t>Fünfte Ebene</a:t>
             </a:r>
-            <a:endParaRPr lang="de-DE"/>
           </a:p>
         </p:txBody>
       </p:sp>
@@ -2076,7 +2058,7 @@
           <a:p>
             <a:pPr lvl="0"/>
             <a:r>
-              <a:rPr lang="de-DE" smtClean="0"/>
+              <a:rPr lang="de-DE"/>
               <a:t>Textmasterformat bearbeiten</a:t>
             </a:r>
           </a:p>
@@ -2099,7 +2081,7 @@
           <a:p>
             <a:fld id="{25EB1AC2-4150-407C-A9A0-54E0CF37BB12}" type="datetimeFigureOut">
               <a:rPr lang="de-DE" smtClean="0"/>
-              <a:t>30.08.2023</a:t>
+              <a:t>11.08.2026</a:t>
             </a:fld>
             <a:endParaRPr lang="de-DE"/>
           </a:p>
@@ -2202,10 +2184,9 @@
           </a:lstStyle>
           <a:p>
             <a:r>
-              <a:rPr lang="de-DE" smtClean="0"/>
+              <a:rPr lang="de-DE"/>
               <a:t>Titelmasterformat durch Klicken bearbeiten</a:t>
             </a:r>
-            <a:endParaRPr lang="de-DE"/>
           </a:p>
         </p:txBody>
       </p:sp>
@@ -2329,7 +2310,7 @@
           <a:p>
             <a:pPr lvl="0"/>
             <a:r>
-              <a:rPr lang="de-DE" smtClean="0"/>
+              <a:rPr lang="de-DE"/>
               <a:t>Textmasterformat bearbeiten</a:t>
             </a:r>
           </a:p>
@@ -2352,7 +2333,7 @@
           <a:p>
             <a:fld id="{25EB1AC2-4150-407C-A9A0-54E0CF37BB12}" type="datetimeFigureOut">
               <a:rPr lang="de-DE" smtClean="0"/>
-              <a:t>30.08.2023</a:t>
+              <a:t>11.08.2026</a:t>
             </a:fld>
             <a:endParaRPr lang="de-DE"/>
           </a:p>
@@ -2461,10 +2442,9 @@
           <a:lstStyle/>
           <a:p>
             <a:r>
-              <a:rPr lang="de-DE" smtClean="0"/>
+              <a:rPr lang="de-DE"/>
               <a:t>Titelmasterformat durch Klicken bearbeiten</a:t>
             </a:r>
-            <a:endParaRPr lang="de-DE"/>
           </a:p>
         </p:txBody>
       </p:sp>
@@ -2495,38 +2475,37 @@
           <a:p>
             <a:pPr lvl="0"/>
             <a:r>
-              <a:rPr lang="de-DE" smtClean="0"/>
+              <a:rPr lang="de-DE"/>
               <a:t>Textmasterformat bearbeiten</a:t>
             </a:r>
           </a:p>
           <a:p>
             <a:pPr lvl="1"/>
             <a:r>
-              <a:rPr lang="de-DE" smtClean="0"/>
+              <a:rPr lang="de-DE"/>
               <a:t>Zweite Ebene</a:t>
             </a:r>
           </a:p>
           <a:p>
             <a:pPr lvl="2"/>
             <a:r>
-              <a:rPr lang="de-DE" smtClean="0"/>
+              <a:rPr lang="de-DE"/>
               <a:t>Dritte Ebene</a:t>
             </a:r>
           </a:p>
           <a:p>
             <a:pPr lvl="3"/>
             <a:r>
-              <a:rPr lang="de-DE" smtClean="0"/>
+              <a:rPr lang="de-DE"/>
               <a:t>Vierte Ebene</a:t>
             </a:r>
           </a:p>
           <a:p>
             <a:pPr lvl="4"/>
             <a:r>
-              <a:rPr lang="de-DE" smtClean="0"/>
+              <a:rPr lang="de-DE"/>
               <a:t>Fünfte Ebene</a:t>
             </a:r>
-            <a:endParaRPr lang="de-DE"/>
           </a:p>
         </p:txBody>
       </p:sp>
@@ -2565,7 +2544,7 @@
           <a:p>
             <a:fld id="{25EB1AC2-4150-407C-A9A0-54E0CF37BB12}" type="datetimeFigureOut">
               <a:rPr lang="de-DE" smtClean="0"/>
-              <a:t>30.08.2023</a:t>
+              <a:t>11.08.2026</a:t>
             </a:fld>
             <a:endParaRPr lang="de-DE"/>
           </a:p>
@@ -3007,14 +2986,14 @@
           <a:p>
             <a:pPr algn="ctr"/>
             <a:r>
-              <a:rPr lang="de-DE" dirty="0" smtClean="0"/>
+              <a:rPr lang="de-DE" dirty="0"/>
               <a:t>ORBIS</a:t>
             </a:r>
             <a:br>
-              <a:rPr lang="de-DE" dirty="0" smtClean="0"/>
+              <a:rPr lang="de-DE" dirty="0"/>
             </a:br>
             <a:r>
-              <a:rPr lang="de-DE" sz="1400" dirty="0" smtClean="0"/>
+              <a:rPr lang="de-DE" sz="1400" dirty="0"/>
               <a:t>Klinisches Arbeitsplatzsystem</a:t>
             </a:r>
             <a:endParaRPr lang="de-DE" dirty="0"/>
@@ -3058,14 +3037,14 @@
           <a:p>
             <a:pPr algn="ctr"/>
             <a:r>
-              <a:rPr lang="de-DE" dirty="0" smtClean="0"/>
+              <a:rPr lang="de-DE" dirty="0"/>
               <a:t>Opus-L</a:t>
             </a:r>
             <a:br>
-              <a:rPr lang="de-DE" dirty="0" smtClean="0"/>
+              <a:rPr lang="de-DE" dirty="0"/>
             </a:br>
             <a:r>
-              <a:rPr lang="de-DE" sz="1400" dirty="0" smtClean="0"/>
+              <a:rPr lang="de-DE" sz="1400" dirty="0"/>
               <a:t>Laborsystem</a:t>
             </a:r>
             <a:endParaRPr lang="de-DE" dirty="0"/>
@@ -3109,18 +3088,14 @@
           <a:p>
             <a:pPr algn="ctr"/>
             <a:r>
-              <a:rPr lang="de-DE" dirty="0" err="1" smtClean="0"/>
+              <a:rPr lang="de-DE" dirty="0" err="1"/>
               <a:t>SeqSphere</a:t>
             </a:r>
-            <a:r>
-              <a:rPr lang="de-DE" dirty="0" smtClean="0"/>
-              <a:t/>
-            </a:r>
             <a:br>
-              <a:rPr lang="de-DE" dirty="0" smtClean="0"/>
+              <a:rPr lang="de-DE" dirty="0"/>
             </a:br>
             <a:r>
-              <a:rPr lang="de-DE" sz="1400" dirty="0" smtClean="0"/>
+              <a:rPr lang="de-DE" sz="1400" dirty="0"/>
               <a:t>Gensequenztool</a:t>
             </a:r>
             <a:endParaRPr lang="de-DE" dirty="0"/>
@@ -3164,18 +3139,14 @@
           <a:p>
             <a:pPr algn="ctr"/>
             <a:r>
-              <a:rPr lang="de-DE" dirty="0" err="1" smtClean="0"/>
+              <a:rPr lang="de-DE" dirty="0" err="1"/>
               <a:t>BaseX</a:t>
             </a:r>
-            <a:r>
-              <a:rPr lang="de-DE" dirty="0" smtClean="0"/>
-              <a:t/>
-            </a:r>
             <a:br>
-              <a:rPr lang="de-DE" dirty="0" smtClean="0"/>
+              <a:rPr lang="de-DE" dirty="0"/>
             </a:br>
             <a:r>
-              <a:rPr lang="de-DE" sz="1400" dirty="0" err="1" smtClean="0"/>
+              <a:rPr lang="de-DE" sz="1400" dirty="0" err="1"/>
               <a:t>Datalake</a:t>
             </a:r>
             <a:endParaRPr lang="de-DE" dirty="0"/>
@@ -3220,17 +3191,16 @@
           <a:p>
             <a:pPr algn="ctr"/>
             <a:r>
-              <a:rPr lang="de-DE" dirty="0" smtClean="0"/>
+              <a:rPr lang="de-DE" dirty="0"/>
               <a:t>HL7 FHIR</a:t>
             </a:r>
             <a:br>
-              <a:rPr lang="de-DE" dirty="0" smtClean="0"/>
+              <a:rPr lang="de-DE" dirty="0"/>
             </a:br>
             <a:r>
-              <a:rPr lang="de-DE" sz="1400" dirty="0" smtClean="0"/>
+              <a:rPr lang="de-DE" sz="1400" dirty="0"/>
               <a:t>MII Kerndatensatz, GECCO</a:t>
             </a:r>
-            <a:endParaRPr lang="de-DE" sz="1400" dirty="0"/>
           </a:p>
         </p:txBody>
       </p:sp>
@@ -3272,7 +3242,7 @@
           <a:p>
             <a:pPr algn="ctr"/>
             <a:r>
-              <a:rPr lang="de-DE" dirty="0" err="1" smtClean="0"/>
+              <a:rPr lang="de-DE" dirty="0" err="1"/>
               <a:t>openEHR</a:t>
             </a:r>
             <a:endParaRPr lang="de-DE" dirty="0"/>
@@ -3316,7 +3286,7 @@
           <a:p>
             <a:pPr algn="ctr"/>
             <a:r>
-              <a:rPr lang="de-DE" dirty="0" err="1" smtClean="0"/>
+              <a:rPr lang="de-DE" dirty="0" err="1"/>
               <a:t>MDReport</a:t>
             </a:r>
             <a:endParaRPr lang="de-DE" dirty="0"/>
@@ -3584,7 +3554,7 @@
           <a:p>
             <a:pPr algn="ctr"/>
             <a:r>
-              <a:rPr lang="de-DE" dirty="0" err="1" smtClean="0"/>
+              <a:rPr lang="de-DE" dirty="0" err="1"/>
               <a:t>Falltage</a:t>
             </a:r>
             <a:endParaRPr lang="de-DE" dirty="0"/>
@@ -3628,10 +3598,9 @@
           <a:p>
             <a:pPr algn="ctr"/>
             <a:r>
-              <a:rPr lang="de-DE" dirty="0" smtClean="0"/>
+              <a:rPr lang="de-DE" dirty="0"/>
               <a:t>Erregertypen</a:t>
             </a:r>
-            <a:endParaRPr lang="de-DE" dirty="0"/>
           </a:p>
         </p:txBody>
       </p:sp>
@@ -3672,10 +3641,9 @@
           <a:p>
             <a:pPr algn="ctr"/>
             <a:r>
-              <a:rPr lang="de-DE" dirty="0" smtClean="0"/>
+              <a:rPr lang="de-DE" dirty="0"/>
               <a:t>Aufenthalte</a:t>
             </a:r>
-            <a:endParaRPr lang="de-DE" dirty="0"/>
           </a:p>
         </p:txBody>
       </p:sp>
@@ -3716,10 +3684,9 @@
           <a:p>
             <a:pPr algn="ctr"/>
             <a:r>
-              <a:rPr lang="de-DE" dirty="0" smtClean="0"/>
+              <a:rPr lang="de-DE" dirty="0"/>
               <a:t>Antibiogramme</a:t>
             </a:r>
-            <a:endParaRPr lang="de-DE" dirty="0"/>
           </a:p>
         </p:txBody>
       </p:sp>
@@ -3760,14 +3727,13 @@
           <a:p>
             <a:pPr algn="ctr"/>
             <a:r>
-              <a:rPr lang="de-DE" dirty="0" err="1" smtClean="0"/>
+              <a:rPr lang="de-DE" dirty="0" err="1"/>
               <a:t>Spa</a:t>
             </a:r>
             <a:r>
-              <a:rPr lang="de-DE" dirty="0" smtClean="0"/>
+              <a:rPr lang="de-DE" dirty="0"/>
               <a:t>-Typ</a:t>
             </a:r>
-            <a:endParaRPr lang="de-DE" dirty="0"/>
           </a:p>
         </p:txBody>
       </p:sp>
@@ -3808,10 +3774,9 @@
           <a:p>
             <a:pPr algn="ctr"/>
             <a:r>
-              <a:rPr lang="de-DE" dirty="0" smtClean="0"/>
+              <a:rPr lang="de-DE" dirty="0"/>
               <a:t>Cluster-Typ</a:t>
             </a:r>
-            <a:endParaRPr lang="de-DE" dirty="0"/>
           </a:p>
         </p:txBody>
       </p:sp>
@@ -3825,13 +3790,6 @@
   <p:clrMapOvr>
     <a:masterClrMapping/>
   </p:clrMapOvr>
-  <p:timing>
-    <p:tnLst>
-      <p:par>
-        <p:cTn id="1" dur="indefinite" restart="never" nodeType="tmRoot"/>
-      </p:par>
-    </p:tnLst>
-  </p:timing>
 </p:sld>
 </file>
 
@@ -3889,30 +3847,30 @@
           <a:p>
             <a:pPr algn="ctr"/>
             <a:r>
-              <a:rPr lang="de-DE" dirty="0" smtClean="0"/>
+              <a:rPr lang="de-DE" dirty="0"/>
               <a:t>ORBIS</a:t>
             </a:r>
             <a:br>
-              <a:rPr lang="de-DE" dirty="0" smtClean="0"/>
+              <a:rPr lang="de-DE" dirty="0"/>
             </a:br>
             <a:r>
-              <a:rPr lang="de-DE" sz="1400" dirty="0" err="1" smtClean="0"/>
+              <a:rPr lang="de-DE" sz="1400" dirty="0" err="1"/>
               <a:t>hospital</a:t>
             </a:r>
             <a:r>
-              <a:rPr lang="de-DE" sz="1400" dirty="0" smtClean="0"/>
+              <a:rPr lang="de-DE" sz="1400" dirty="0"/>
               <a:t> </a:t>
             </a:r>
             <a:r>
-              <a:rPr lang="de-DE" sz="1400" dirty="0" err="1" smtClean="0"/>
+              <a:rPr lang="de-DE" sz="1400" dirty="0" err="1"/>
               <a:t>information</a:t>
             </a:r>
             <a:r>
-              <a:rPr lang="de-DE" sz="1400" dirty="0" smtClean="0"/>
+              <a:rPr lang="de-DE" sz="1400" dirty="0"/>
               <a:t> </a:t>
             </a:r>
             <a:r>
-              <a:rPr lang="de-DE" sz="1400" dirty="0" err="1" smtClean="0"/>
+              <a:rPr lang="de-DE" sz="1400" dirty="0" err="1"/>
               <a:t>system</a:t>
             </a:r>
             <a:endParaRPr lang="de-DE" dirty="0"/>
@@ -3956,22 +3914,18 @@
           <a:p>
             <a:pPr algn="ctr"/>
             <a:r>
-              <a:rPr lang="de-DE" dirty="0" smtClean="0"/>
+              <a:rPr lang="de-DE" dirty="0"/>
               <a:t>Opus-L</a:t>
             </a:r>
             <a:br>
-              <a:rPr lang="de-DE" dirty="0" smtClean="0"/>
+              <a:rPr lang="de-DE" dirty="0"/>
             </a:br>
             <a:r>
-              <a:rPr lang="de-DE" sz="1400" dirty="0" err="1" smtClean="0"/>
-              <a:t>l</a:t>
-            </a:r>
-            <a:r>
-              <a:rPr lang="de-DE" sz="1400" dirty="0" err="1" smtClean="0"/>
-              <a:t>aboratory</a:t>
-            </a:r>
-            <a:r>
-              <a:rPr lang="de-DE" sz="1400" dirty="0" smtClean="0"/>
+              <a:rPr lang="de-DE" sz="1400" dirty="0" err="1"/>
+              <a:t>laboratory</a:t>
+            </a:r>
+            <a:r>
+              <a:rPr lang="de-DE" sz="1400" dirty="0"/>
               <a:t> </a:t>
             </a:r>
             <a:r>
@@ -4035,30 +3989,22 @@
           <a:p>
             <a:pPr algn="ctr"/>
             <a:r>
-              <a:rPr lang="de-DE" dirty="0" err="1" smtClean="0"/>
+              <a:rPr lang="de-DE" dirty="0" err="1"/>
               <a:t>SeqSphere</a:t>
             </a:r>
             <a:r>
-              <a:rPr lang="de-DE" dirty="0" smtClean="0"/>
+              <a:rPr lang="de-DE" dirty="0"/>
               <a:t>+</a:t>
             </a:r>
-            <a:r>
-              <a:rPr lang="de-DE" dirty="0" smtClean="0"/>
-              <a:t/>
-            </a:r>
             <a:br>
-              <a:rPr lang="de-DE" dirty="0" smtClean="0"/>
+              <a:rPr lang="de-DE" dirty="0"/>
             </a:br>
             <a:r>
-              <a:rPr lang="de-DE" sz="1400" dirty="0" err="1" smtClean="0"/>
-              <a:t>m</a:t>
-            </a:r>
-            <a:r>
-              <a:rPr lang="de-DE" sz="1400" dirty="0" err="1" smtClean="0"/>
-              <a:t>icrobial</a:t>
-            </a:r>
-            <a:r>
-              <a:rPr lang="de-DE" sz="1400" dirty="0" smtClean="0"/>
+              <a:rPr lang="de-DE" sz="1400" dirty="0" err="1"/>
+              <a:t>microbial</a:t>
+            </a:r>
+            <a:r>
+              <a:rPr lang="de-DE" sz="1400" dirty="0"/>
               <a:t> </a:t>
             </a:r>
             <a:r>
@@ -4114,18 +4060,14 @@
           <a:p>
             <a:pPr algn="ctr"/>
             <a:r>
-              <a:rPr lang="de-DE" dirty="0" err="1" smtClean="0"/>
+              <a:rPr lang="de-DE" dirty="0" err="1"/>
               <a:t>BaseX</a:t>
             </a:r>
-            <a:r>
-              <a:rPr lang="de-DE" dirty="0" smtClean="0"/>
-              <a:t/>
-            </a:r>
             <a:br>
-              <a:rPr lang="de-DE" dirty="0" smtClean="0"/>
+              <a:rPr lang="de-DE" dirty="0"/>
             </a:br>
             <a:r>
-              <a:rPr lang="de-DE" sz="1400" dirty="0" err="1" smtClean="0"/>
+              <a:rPr lang="de-DE" sz="1400" dirty="0" err="1"/>
               <a:t>Datalake</a:t>
             </a:r>
             <a:endParaRPr lang="de-DE" dirty="0"/>
@@ -4170,17 +4112,16 @@
           <a:p>
             <a:pPr algn="ctr"/>
             <a:r>
-              <a:rPr lang="de-DE" dirty="0" smtClean="0"/>
+              <a:rPr lang="de-DE" dirty="0"/>
               <a:t>HL7 FHIR</a:t>
             </a:r>
             <a:br>
-              <a:rPr lang="de-DE" dirty="0" smtClean="0"/>
+              <a:rPr lang="de-DE" dirty="0"/>
             </a:br>
             <a:r>
-              <a:rPr lang="de-DE" sz="1400" dirty="0" smtClean="0"/>
+              <a:rPr lang="de-DE" sz="1400" dirty="0"/>
               <a:t>MII Kerndatensatz, GECCO</a:t>
             </a:r>
-            <a:endParaRPr lang="de-DE" sz="1400" dirty="0"/>
           </a:p>
         </p:txBody>
       </p:sp>
@@ -4222,7 +4163,7 @@
           <a:p>
             <a:pPr algn="ctr"/>
             <a:r>
-              <a:rPr lang="de-DE" dirty="0" err="1" smtClean="0"/>
+              <a:rPr lang="de-DE" dirty="0" err="1"/>
               <a:t>openEHR</a:t>
             </a:r>
             <a:endParaRPr lang="de-DE" dirty="0"/>
@@ -4266,8 +4207,8 @@
           <a:p>
             <a:pPr algn="ctr"/>
             <a:r>
-              <a:rPr lang="de-DE" dirty="0" err="1" smtClean="0"/>
-              <a:t>MREReport</a:t>
+              <a:rPr lang="de-DE" dirty="0" err="1"/>
+              <a:t>MDROReport</a:t>
             </a:r>
             <a:endParaRPr lang="de-DE" dirty="0"/>
           </a:p>
@@ -4460,15 +4401,15 @@
           <a:p>
             <a:pPr algn="ctr"/>
             <a:r>
-              <a:rPr lang="de-DE" dirty="0" err="1" smtClean="0"/>
+              <a:rPr lang="de-DE" dirty="0" err="1"/>
               <a:t>patient</a:t>
             </a:r>
             <a:r>
-              <a:rPr lang="de-DE" dirty="0" smtClean="0"/>
+              <a:rPr lang="de-DE" dirty="0"/>
               <a:t> </a:t>
             </a:r>
             <a:r>
-              <a:rPr lang="de-DE" dirty="0" err="1" smtClean="0"/>
+              <a:rPr lang="de-DE" dirty="0" err="1"/>
               <a:t>days</a:t>
             </a:r>
             <a:endParaRPr lang="de-DE" dirty="0"/>
@@ -4513,14 +4454,10 @@
             <a:pPr algn="ctr"/>
             <a:r>
               <a:rPr lang="de-DE" dirty="0"/>
-              <a:t>p</a:t>
-            </a:r>
-            <a:r>
-              <a:rPr lang="de-DE" dirty="0" smtClean="0"/>
-              <a:t>athogen </a:t>
-            </a:r>
-            <a:r>
-              <a:rPr lang="de-DE" dirty="0" err="1" smtClean="0"/>
+              <a:t>pathogen </a:t>
+            </a:r>
+            <a:r>
+              <a:rPr lang="de-DE" dirty="0" err="1"/>
               <a:t>types</a:t>
             </a:r>
             <a:endParaRPr lang="de-DE" dirty="0"/>
@@ -4564,15 +4501,15 @@
           <a:p>
             <a:pPr algn="ctr"/>
             <a:r>
-              <a:rPr lang="de-DE" dirty="0" err="1" smtClean="0"/>
+              <a:rPr lang="de-DE" dirty="0" err="1"/>
               <a:t>patient</a:t>
             </a:r>
             <a:r>
-              <a:rPr lang="de-DE" dirty="0" smtClean="0"/>
+              <a:rPr lang="de-DE" dirty="0"/>
               <a:t> </a:t>
             </a:r>
             <a:r>
-              <a:rPr lang="de-DE" dirty="0" err="1" smtClean="0"/>
+              <a:rPr lang="de-DE" dirty="0" err="1"/>
               <a:t>location</a:t>
             </a:r>
             <a:endParaRPr lang="de-DE" dirty="0"/>
@@ -4616,7 +4553,7 @@
           <a:p>
             <a:pPr algn="ctr"/>
             <a:r>
-              <a:rPr lang="de-DE" dirty="0" err="1" smtClean="0"/>
+              <a:rPr lang="de-DE" dirty="0" err="1"/>
               <a:t>antibiograms</a:t>
             </a:r>
             <a:endParaRPr lang="de-DE" dirty="0"/>
@@ -4660,18 +4597,13 @@
           <a:p>
             <a:pPr algn="ctr"/>
             <a:r>
-              <a:rPr lang="de-DE" dirty="0" err="1" smtClean="0"/>
+              <a:rPr lang="de-DE" dirty="0" err="1"/>
               <a:t>spa</a:t>
             </a:r>
             <a:r>
-              <a:rPr lang="de-DE" dirty="0" smtClean="0"/>
-              <a:t> t</a:t>
-            </a:r>
-            <a:r>
-              <a:rPr lang="de-DE" dirty="0" smtClean="0"/>
-              <a:t>ype</a:t>
-            </a:r>
-            <a:endParaRPr lang="de-DE" dirty="0"/>
+              <a:rPr lang="de-DE" dirty="0"/>
+              <a:t> type</a:t>
+            </a:r>
           </a:p>
         </p:txBody>
       </p:sp>
@@ -4713,17 +4645,12 @@
             <a:pPr algn="ctr"/>
             <a:r>
               <a:rPr lang="de-DE" dirty="0" err="1"/>
-              <a:t>c</a:t>
-            </a:r>
-            <a:r>
-              <a:rPr lang="de-DE" dirty="0" err="1" smtClean="0"/>
-              <a:t>luster</a:t>
-            </a:r>
-            <a:r>
-              <a:rPr lang="de-DE" dirty="0" smtClean="0"/>
+              <a:t>cluster</a:t>
+            </a:r>
+            <a:r>
+              <a:rPr lang="de-DE" dirty="0"/>
               <a:t> type</a:t>
             </a:r>
-            <a:endParaRPr lang="de-DE" dirty="0"/>
           </a:p>
         </p:txBody>
       </p:sp>
@@ -4737,13 +4664,6 @@
   <p:clrMapOvr>
     <a:masterClrMapping/>
   </p:clrMapOvr>
-  <p:timing>
-    <p:tnLst>
-      <p:par>
-        <p:cTn id="1" dur="indefinite" restart="never" nodeType="tmRoot"/>
-      </p:par>
-    </p:tnLst>
-  </p:timing>
 </p:sld>
 </file>
 

</xml_diff>